<commit_message>
Rework sisimimi to follow supplied S-Chicken reference
</commit_message>
<xml_diff>
--- a/sisimimi/docs/BAO_CAO.pptx
+++ b/sisimimi/docs/BAO_CAO.pptx
@@ -6037,7 +6037,7 @@
               </a:defRPr>
             </a:pPr>
             <a:r>
-              <a:t>Nguồn dữ liệu chung; kiểm tra ID/số lượng; đường dẫn tương đối; media query.</a:t>
+              <a:t>Tách 3 script; đồng bộ card HTML; kiểm tra ID/số lượng và sửa lỗi của mẫu tham chiếu.</a:t>
             </a:r>
           </a:p>
         </p:txBody>
@@ -9758,7 +9758,7 @@
           <a:p>
             <a:pPr>
               <a:spcAft>
-                <a:spcPts val="1200"/>
+                <a:spcPts val="700"/>
               </a:spcAft>
               <a:defRPr sz="2200" b="0">
                 <a:solidFill>
@@ -9768,13 +9768,14 @@
               </a:defRPr>
             </a:pPr>
             <a:r>
+              <a:rPr sz="1800"/>
               <a:t>sisimimi/</a:t>
             </a:r>
           </a:p>
           <a:p>
             <a:pPr>
               <a:spcAft>
-                <a:spcPts val="1200"/>
+                <a:spcPts val="700"/>
               </a:spcAft>
               <a:defRPr sz="2200" b="0">
                 <a:solidFill>
@@ -9784,13 +9785,14 @@
               </a:defRPr>
             </a:pPr>
             <a:r>
+              <a:rPr sz="1800"/>
               <a:t>  11 tệp HTML</a:t>
             </a:r>
           </a:p>
           <a:p>
             <a:pPr>
               <a:spcAft>
-                <a:spcPts val="1200"/>
+                <a:spcPts val="700"/>
               </a:spcAft>
               <a:defRPr sz="2200" b="0">
                 <a:solidFill>
@@ -9800,13 +9802,14 @@
               </a:defRPr>
             </a:pPr>
             <a:r>
+              <a:rPr sz="1800"/>
               <a:t>  css/style.css</a:t>
             </a:r>
           </a:p>
           <a:p>
             <a:pPr>
               <a:spcAft>
-                <a:spcPts val="1200"/>
+                <a:spcPts val="700"/>
               </a:spcAft>
               <a:defRPr sz="2200" b="0">
                 <a:solidFill>
@@ -9816,13 +9819,16 @@
               </a:defRPr>
             </a:pPr>
             <a:r>
-              <a:t>  js/script.js</a:t>
-            </a:r>
-          </a:p>
-          <a:p>
-            <a:pPr>
-              <a:spcAft>
-                <a:spcPts val="1200"/>
+              <a:rPr sz="1800"/>
+              <a:t>  js/products.js
+  js/cart.js
+  js/main.js</a:t>
+            </a:r>
+          </a:p>
+          <a:p>
+            <a:pPr>
+              <a:spcAft>
+                <a:spcPts val="700"/>
               </a:spcAft>
               <a:defRPr sz="2200" b="0">
                 <a:solidFill>
@@ -9832,13 +9838,14 @@
               </a:defRPr>
             </a:pPr>
             <a:r>
+              <a:rPr sz="1800"/>
               <a:t>  images/</a:t>
             </a:r>
           </a:p>
           <a:p>
             <a:pPr>
               <a:spcAft>
-                <a:spcPts val="1200"/>
+                <a:spcPts val="700"/>
               </a:spcAft>
               <a:defRPr sz="2200" b="0">
                 <a:solidFill>
@@ -9848,6 +9855,7 @@
               </a:defRPr>
             </a:pPr>
             <a:r>
+              <a:rPr sz="1800"/>
               <a:t>  docs/</a:t>
             </a:r>
           </a:p>
@@ -9919,7 +9927,7 @@
               </a:defRPr>
             </a:pPr>
             <a:r>
-              <a:t>JavaScript: dữ liệu và các thao tác.</a:t>
+              <a:t>3 script: dữ liệu, giỏ, tương tác.</a:t>
             </a:r>
           </a:p>
           <a:p>
@@ -11092,30 +11100,6 @@
           </a:p>
         </p:txBody>
       </p:sp>
-      <p:pic>
-        <p:nvPicPr>
-          <p:cNvPr id="6" name="Picture 5" descr="giao-dien-trang-chu.png"/>
-          <p:cNvPicPr>
-            <a:picLocks noChangeAspect="1"/>
-          </p:cNvPicPr>
-          <p:nvPr/>
-        </p:nvPicPr>
-        <p:blipFill>
-          <a:blip r:embed="rId2"/>
-          <a:stretch>
-            <a:fillRect/>
-          </a:stretch>
-        </p:blipFill>
-        <p:spPr>
-          <a:xfrm>
-            <a:off x="594360" y="1965960"/>
-            <a:ext cx="5285232" cy="3716121"/>
-          </a:xfrm>
-          <a:prstGeom prst="rect">
-            <a:avLst/>
-          </a:prstGeom>
-        </p:spPr>
-      </p:pic>
       <p:sp>
         <p:nvSpPr>
           <p:cNvPr id="7" name="TextBox 6"/>
@@ -11195,30 +11179,6 @@
           </a:p>
         </p:txBody>
       </p:sp>
-      <p:pic>
-        <p:nvPicPr>
-          <p:cNvPr id="9" name="Picture 8" descr="giao-dien-san-pham.png"/>
-          <p:cNvPicPr>
-            <a:picLocks noChangeAspect="1"/>
-          </p:cNvPicPr>
-          <p:nvPr/>
-        </p:nvPicPr>
-        <p:blipFill>
-          <a:blip r:embed="rId3"/>
-          <a:stretch>
-            <a:fillRect/>
-          </a:stretch>
-        </p:blipFill>
-        <p:spPr>
-          <a:xfrm>
-            <a:off x="6355080" y="1965960"/>
-            <a:ext cx="5285232" cy="3716121"/>
-          </a:xfrm>
-          <a:prstGeom prst="rect">
-            <a:avLst/>
-          </a:prstGeom>
-        </p:spPr>
-      </p:pic>
       <p:sp>
         <p:nvSpPr>
           <p:cNvPr id="10" name="TextBox 9"/>
@@ -11406,6 +11366,54 @@
           </a:p>
         </p:txBody>
       </p:sp>
+      <p:pic>
+        <p:nvPicPr>
+          <p:cNvPr id="15" name="Picture 14" descr="giao-dien-trang-chu.png"/>
+          <p:cNvPicPr>
+            <a:picLocks noChangeAspect="1"/>
+          </p:cNvPicPr>
+          <p:nvPr/>
+        </p:nvPicPr>
+        <p:blipFill>
+          <a:blip r:embed="rId4"/>
+          <a:stretch>
+            <a:fillRect/>
+          </a:stretch>
+        </p:blipFill>
+        <p:spPr>
+          <a:xfrm>
+            <a:off x="594360" y="1965960"/>
+            <a:ext cx="5285232" cy="3716121"/>
+          </a:xfrm>
+          <a:prstGeom prst="rect">
+            <a:avLst/>
+          </a:prstGeom>
+        </p:spPr>
+      </p:pic>
+      <p:pic>
+        <p:nvPicPr>
+          <p:cNvPr id="16" name="Picture 15" descr="giao-dien-san-pham.png"/>
+          <p:cNvPicPr>
+            <a:picLocks noChangeAspect="1"/>
+          </p:cNvPicPr>
+          <p:nvPr/>
+        </p:nvPicPr>
+        <p:blipFill>
+          <a:blip r:embed="rId5"/>
+          <a:stretch>
+            <a:fillRect/>
+          </a:stretch>
+        </p:blipFill>
+        <p:spPr>
+          <a:xfrm>
+            <a:off x="6355080" y="1965960"/>
+            <a:ext cx="5285232" cy="3716121"/>
+          </a:xfrm>
+          <a:prstGeom prst="rect">
+            <a:avLst/>
+          </a:prstGeom>
+        </p:spPr>
+      </p:pic>
     </p:spTree>
   </p:cSld>
   <p:clrMapOvr>
@@ -11790,7 +11798,7 @@
               </a:defRPr>
             </a:pPr>
             <a:r>
-              <a:t>Mảng sản phẩm chứa ID, tên, giá, danh mục, ảnh và đặc điểm.</a:t>
+              <a:t>products.js chứa dữ liệu, tên danh mục, định dạng tiền và hàm tìm theo ID.</a:t>
             </a:r>
           </a:p>
         </p:txBody>
@@ -11911,7 +11919,7 @@
               </a:defRPr>
             </a:pPr>
             <a:r>
-              <a:t>Tìm theo tên và chọn 4 nhóm: thức ăn, đồ chơi, quần áo, phụ kiện.</a:t>
+              <a:t>Card có sẵn trong HTML; main.js ẩn/hiện product-wrapper theo từ khóa và danh mục.</a:t>
             </a:r>
           </a:p>
         </p:txBody>
@@ -12032,7 +12040,7 @@
               </a:defRPr>
             </a:pPr>
             <a:r>
-              <a:t>?id=1 chọn nội dung tương ứng. Có thông báo nếu không tìm thấy sản phẩm hoặc bài viết.</a:t>
+              <a:t>main.js đọc ?id=1, hiện đúng nội dung và tối đa 4 sản phẩm liên quan; ID lạ có thông báo.</a:t>
             </a:r>
           </a:p>
         </p:txBody>

</xml_diff>

<commit_message>
Make sisimimi dog-only with transparent product photos
</commit_message>
<xml_diff>
--- a/sisimimi/docs/BAO_CAO.pptx
+++ b/sisimimi/docs/BAO_CAO.pptx
@@ -3440,7 +3440,7 @@
               </a:defRPr>
             </a:pPr>
             <a:r>
-              <a:t>Website đồ dùng và phụ kiện cho chó, mèo</a:t>
+              <a:t>Website đồ dùng và phụ kiện cho chó và cún con</a:t>
             </a:r>
           </a:p>
           <a:p>
@@ -6158,7 +6158,7 @@
               </a:defRPr>
             </a:pPr>
             <a:r>
-              <a:t>Dữ liệu cửa hàng và đánh giá là mẫu. Bản đồ cần mạng. Không có backend hay giao dịch thật.</a:t>
+              <a:t>Ảnh PNG sản phẩm do AI tạo để minh họa; không chứng thực hàng vật lý. Bản đồ cần mạng. Không có giao dịch thật.</a:t>
             </a:r>
           </a:p>
         </p:txBody>
@@ -6504,7 +6504,7 @@
               </a:defRPr>
             </a:pPr>
             <a:r>
-              <a:t>Bổ sung ảnh thật có quyền sử dụng.</a:t>
+              <a:t>Bổ sung ảnh hàng thật có quyền sử dụng.</a:t>
             </a:r>
           </a:p>
           <a:p>
@@ -7222,7 +7222,7 @@
               </a:defRPr>
             </a:pPr>
             <a:r>
-              <a:t>Đồ dùng, thức ăn, quần áo và phụ kiện dành cho chó, mèo.</a:t>
+              <a:t>Đồ dùng, thức ăn, quần áo và phụ kiện dành cho chó và cún con.</a:t>
             </a:r>
           </a:p>
         </p:txBody>
@@ -7814,7 +7814,7 @@
               </a:defRPr>
             </a:pPr>
             <a:r>
-              <a:t>Chủ đề gần gũi, phù hợp dữ liệu và hình minh họa mẫu.</a:t>
+              <a:t>Chủ đề chó/cún gần gũi; ảnh PNG tách nền dùng cho sản phẩm mẫu.</a:t>
             </a:r>
           </a:p>
         </p:txBody>
@@ -9943,7 +9943,8 @@
               </a:defRPr>
             </a:pPr>
             <a:r>
-              <a:t>Ảnh: minh họa SVG cục bộ.</a:t>
+              <a:t>Ảnh: 12 PNG sản phẩm + hero-dogs.png.
+4 SVG: logo và 3 chân dung đội ngũ.</a:t>
             </a:r>
           </a:p>
           <a:p>
@@ -11375,7 +11376,7 @@
           <p:nvPr/>
         </p:nvPicPr>
         <p:blipFill>
-          <a:blip r:embed="rId4"/>
+          <a:blip r:embed="rId6"/>
           <a:stretch>
             <a:fillRect/>
           </a:stretch>
@@ -11399,7 +11400,7 @@
           <p:nvPr/>
         </p:nvPicPr>
         <p:blipFill>
-          <a:blip r:embed="rId5"/>
+          <a:blip r:embed="rId7"/>
           <a:stretch>
             <a:fillRect/>
           </a:stretch>

</xml_diff>